<commit_message>
trying to fix broken links for slides in m3
</commit_message>
<xml_diff>
--- a/Slides/Module 03.1 Trusting TypeScript.pptx
+++ b/Slides/Module 03.1 Trusting TypeScript.pptx
@@ -264,7 +264,7 @@
           <a:p>
             <a:fld id="{7C7E5181-6CF5-45F7-A87A-E0E0B1FD7549}" type="datetimeFigureOut">
               <a:rPr lang="en-US" smtClean="0"/>
-              <a:t>1/12/26</a:t>
+              <a:t>1/15/2026</a:t>
             </a:fld>
             <a:endParaRPr lang="en-US"/>
           </a:p>
@@ -3646,7 +3646,7 @@
           <a:p>
             <a:fld id="{5D2A64DE-480B-420F-9649-4F8E696E08E0}" type="datetime1">
               <a:rPr lang="en-US" smtClean="0"/>
-              <a:t>1/12/26</a:t>
+              <a:t>1/15/2026</a:t>
             </a:fld>
             <a:endParaRPr lang="en-US"/>
           </a:p>
@@ -3970,7 +3970,7 @@
           <a:p>
             <a:fld id="{EA476A42-A091-4468-A075-64A31BE59948}" type="datetime1">
               <a:rPr lang="en-US" smtClean="0"/>
-              <a:t>1/12/26</a:t>
+              <a:t>1/15/2026</a:t>
             </a:fld>
             <a:endParaRPr lang="en-US"/>
           </a:p>
@@ -4168,7 +4168,7 @@
           <a:p>
             <a:fld id="{0D3616D0-8311-4107-9726-6B805E7D05BA}" type="datetime1">
               <a:rPr lang="en-US" smtClean="0"/>
-              <a:t>1/12/26</a:t>
+              <a:t>1/15/2026</a:t>
             </a:fld>
             <a:endParaRPr lang="en-US"/>
           </a:p>
@@ -4376,7 +4376,7 @@
           <a:p>
             <a:fld id="{3BC2557A-5C88-417A-A763-5AC779462A5F}" type="datetime1">
               <a:rPr lang="en-US" smtClean="0"/>
-              <a:t>1/12/26</a:t>
+              <a:t>1/15/2026</a:t>
             </a:fld>
             <a:endParaRPr lang="en-US"/>
           </a:p>
@@ -4798,7 +4798,7 @@
           <a:p>
             <a:fld id="{07C7BFD4-467E-4EDE-93EA-052F5B39A4E5}" type="datetime1">
               <a:rPr lang="en-US" smtClean="0"/>
-              <a:t>1/12/26</a:t>
+              <a:t>1/15/2026</a:t>
             </a:fld>
             <a:endParaRPr lang="en-US"/>
           </a:p>
@@ -5048,7 +5048,7 @@
           <a:p>
             <a:fld id="{07C7BFD4-467E-4EDE-93EA-052F5B39A4E5}" type="datetime1">
               <a:rPr lang="en-US" smtClean="0"/>
-              <a:t>1/12/26</a:t>
+              <a:t>1/15/2026</a:t>
             </a:fld>
             <a:endParaRPr lang="en-US"/>
           </a:p>
@@ -5230,7 +5230,7 @@
           <a:p>
             <a:fld id="{109E55A0-C911-4F03-82FC-7E5926047D46}" type="datetime1">
               <a:rPr lang="en-US" smtClean="0"/>
-              <a:t>1/12/26</a:t>
+              <a:t>1/15/2026</a:t>
             </a:fld>
             <a:endParaRPr lang="en-US"/>
           </a:p>
@@ -5543,7 +5543,7 @@
           <a:p>
             <a:fld id="{A533CBE2-D5BE-47AC-ADC2-9CDFC1D0CF90}" type="datetime1">
               <a:rPr lang="en-US" smtClean="0"/>
-              <a:t>1/12/26</a:t>
+              <a:t>1/15/2026</a:t>
             </a:fld>
             <a:endParaRPr lang="en-US"/>
           </a:p>
@@ -5844,7 +5844,7 @@
           <a:p>
             <a:fld id="{39B7EDB1-CE74-4951-85A2-0B01C2128E28}" type="datetime1">
               <a:rPr lang="en-US" smtClean="0"/>
-              <a:t>1/12/26</a:t>
+              <a:t>1/15/2026</a:t>
             </a:fld>
             <a:endParaRPr lang="en-US"/>
           </a:p>
@@ -6292,7 +6292,7 @@
           <a:p>
             <a:fld id="{2BC7EB92-A5C2-4807-A9DC-9EDE6CBFB241}" type="datetime1">
               <a:rPr lang="en-US" smtClean="0"/>
-              <a:t>1/12/26</a:t>
+              <a:t>1/15/2026</a:t>
             </a:fld>
             <a:endParaRPr lang="en-US"/>
           </a:p>
@@ -6405,7 +6405,7 @@
           <a:p>
             <a:fld id="{2B7B7EE0-7771-4CD5-9B2B-3550753A54A1}" type="datetime1">
               <a:rPr lang="en-US" smtClean="0"/>
-              <a:t>1/12/26</a:t>
+              <a:t>1/15/2026</a:t>
             </a:fld>
             <a:endParaRPr lang="en-US"/>
           </a:p>
@@ -6716,7 +6716,7 @@
           <a:p>
             <a:fld id="{F8B318B3-0E87-4416-A9B8-D891968C2727}" type="datetime1">
               <a:rPr lang="en-US" smtClean="0"/>
-              <a:t>1/12/26</a:t>
+              <a:t>1/15/2026</a:t>
             </a:fld>
             <a:endParaRPr lang="en-US"/>
           </a:p>
@@ -6957,7 +6957,7 @@
           <a:p>
             <a:fld id="{54D997E8-DDEE-43F1-8D9B-F8A1E11DE488}" type="datetime1">
               <a:rPr lang="en-US" smtClean="0"/>
-              <a:t>1/12/26</a:t>
+              <a:t>1/15/2026</a:t>
             </a:fld>
             <a:endParaRPr lang="en-US"/>
           </a:p>
@@ -20208,8 +20208,8 @@
         </p:nvSpPr>
         <p:spPr>
           <a:xfrm>
-            <a:off x="1779105" y="1807319"/>
-            <a:ext cx="8975035" cy="2062103"/>
+            <a:off x="1779105" y="2214943"/>
+            <a:ext cx="8975035" cy="1569660"/>
           </a:xfrm>
           <a:prstGeom prst="rect">
             <a:avLst/>
@@ -20242,7 +20242,7 @@
           <a:p>
             <a:pPr algn="ctr" hangingPunct="0"/>
             <a:r>
-              <a:rPr lang="en-US" sz="6400" dirty="0">
+              <a:rPr lang="en-US" sz="4800" dirty="0">
                 <a:solidFill>
                   <a:schemeClr val="accent5">
                     <a:lumMod val="75000"/>

</xml_diff>